<commit_message>
docs: designate Hemish Jain as Team Lead and Primary Member across all submission materials
- Updated presentation slides (SRMIST_FixFlow_Submission.pptx, PDF, and template copy) with Hemish Jain as Team Lead & Primary Member.
- Updated AI Disclosure forms (SRMIST_FixFlow_AI_Disclosure.docx & LangAI3.0_AI_Disclosure.docx) with Hemish Jain as Team Lead & Primary Representative.
- Updated README.md with dedicated Team Details section.
- Synchronized docs/FixFlow_TwoDev_Plan.md, docs/tasks.md, and docs/Jules_Workflow_Guide.md.
</commit_message>
<xml_diff>
--- a/CollegeName_TeamName_Submission.pptx
+++ b/CollegeName_TeamName_Submission.pptx
@@ -4245,7 +4245,7 @@
               </a:defRPr>
             </a:pPr>
             <a:r>
-              <a:t>Team Lead: </a:t>
+              <a:t>Team Lead &amp; Primary Member: </a:t>
             </a:r>
             <a:r>
               <a:rPr b="0" sz="1600">
@@ -4253,7 +4253,30 @@
                   <a:srgbClr val="1A4B8C"/>
                 </a:solidFill>
               </a:rPr>
-              <a:t>Mridul Mathur (mridul.mat@outlook.com)</a:t>
+              <a:t>Hemish Jain</a:t>
+            </a:r>
+          </a:p>
+          <a:p>
+            <a:pPr>
+              <a:spcAft>
+                <a:spcPts val="800"/>
+              </a:spcAft>
+              <a:defRPr b="1" sz="1600">
+                <a:solidFill>
+                  <a:srgbClr val="1E293B"/>
+                </a:solidFill>
+              </a:defRPr>
+            </a:pPr>
+            <a:r>
+              <a:t>Team Member: </a:t>
+            </a:r>
+            <a:r>
+              <a:rPr b="0" sz="1600">
+                <a:solidFill>
+                  <a:srgbClr val="1A4B8C"/>
+                </a:solidFill>
+              </a:rPr>
+              <a:t>Mridul Mathur</a:t>
             </a:r>
           </a:p>
           <a:p>

</xml_diff>

<commit_message>
docs: update team emails to official SRMIST addresses (hj0012@srmist.edu.in, mm4956@srmist.edu.in)
</commit_message>
<xml_diff>
--- a/CollegeName_TeamName_Submission.pptx
+++ b/CollegeName_TeamName_Submission.pptx
@@ -4276,7 +4276,7 @@
                   <a:srgbClr val="1A4B8C"/>
                 </a:solidFill>
               </a:rPr>
-              <a:t>Hemish Jain</a:t>
+              <a:t>Hemish Jain (hj0012@srmist.edu.in)</a:t>
             </a:r>
           </a:p>
           <a:p>
@@ -4299,7 +4299,7 @@
                   <a:srgbClr val="1A4B8C"/>
                 </a:solidFill>
               </a:rPr>
-              <a:t>Mridul Mathur</a:t>
+              <a:t>Mridul Mathur (mm4956@srmist.edu.in)</a:t>
             </a:r>
           </a:p>
           <a:p>

</xml_diff>